<commit_message>
fix(lab06): refine editable slide captions and changelog links
</commit_message>
<xml_diff>
--- a/labs/lab06/presentation/simulation-modeling-lab06-presentation.pptx
+++ b/labs/lab06/presentation/simulation-modeling-lab06-presentation.pptx
@@ -2,33 +2,33 @@
 <file path=ppt/presentation.xml><?xml version="1.0" encoding="utf-8"?>
 <p:presentation xmlns:p="http://schemas.openxmlformats.org/presentationml/2006/main">
   <p:sldMasterIdLst>
-    <p:sldMasterId xmlns:r="http://schemas.openxmlformats.org/officeDocument/2006/relationships" id="2147483648" r:id="Rd5320a86a7d941cc"/>
+    <p:sldMasterId xmlns:r="http://schemas.openxmlformats.org/officeDocument/2006/relationships" id="2147483648" r:id="Rc8f5fa09a7a74d45"/>
   </p:sldMasterIdLst>
   <p:notesMasterIdLst>
-    <p:notesMasterId xmlns:r="http://schemas.openxmlformats.org/officeDocument/2006/relationships" r:id="R396e57d2986f47cd"/>
+    <p:notesMasterId xmlns:r="http://schemas.openxmlformats.org/officeDocument/2006/relationships" r:id="R1bab8260a37e4225"/>
   </p:notesMasterIdLst>
   <p:sldIdLst>
-    <p:sldId xmlns:r="http://schemas.openxmlformats.org/officeDocument/2006/relationships" id="256" r:id="R9ac858bc0f2c4515"/>
-    <p:sldId xmlns:r="http://schemas.openxmlformats.org/officeDocument/2006/relationships" id="257" r:id="R689ea2dc67154141"/>
-    <p:sldId xmlns:r="http://schemas.openxmlformats.org/officeDocument/2006/relationships" id="258" r:id="Rbf38b5e2079047c3"/>
-    <p:sldId xmlns:r="http://schemas.openxmlformats.org/officeDocument/2006/relationships" id="259" r:id="R1bb7c24bad1e4408"/>
-    <p:sldId xmlns:r="http://schemas.openxmlformats.org/officeDocument/2006/relationships" id="260" r:id="R6e51f8fa87d24e37"/>
-    <p:sldId xmlns:r="http://schemas.openxmlformats.org/officeDocument/2006/relationships" id="261" r:id="R02815a83a0bc4b13"/>
-    <p:sldId xmlns:r="http://schemas.openxmlformats.org/officeDocument/2006/relationships" id="262" r:id="R58fc1e92f9014d31"/>
-    <p:sldId xmlns:r="http://schemas.openxmlformats.org/officeDocument/2006/relationships" id="263" r:id="Rba56fbd4def94f32"/>
-    <p:sldId xmlns:r="http://schemas.openxmlformats.org/officeDocument/2006/relationships" id="264" r:id="R98ffebafeb6248dc"/>
-    <p:sldId xmlns:r="http://schemas.openxmlformats.org/officeDocument/2006/relationships" id="265" r:id="R5d388dc96b8649f3"/>
-    <p:sldId xmlns:r="http://schemas.openxmlformats.org/officeDocument/2006/relationships" id="266" r:id="R7d53d2690e0d4a64"/>
-    <p:sldId xmlns:r="http://schemas.openxmlformats.org/officeDocument/2006/relationships" id="267" r:id="R101092521cb14a9e"/>
-    <p:sldId xmlns:r="http://schemas.openxmlformats.org/officeDocument/2006/relationships" id="268" r:id="R0c8f2691db6e4c56"/>
-    <p:sldId xmlns:r="http://schemas.openxmlformats.org/officeDocument/2006/relationships" id="269" r:id="R3d6856dc8bbc4ca0"/>
-    <p:sldId xmlns:r="http://schemas.openxmlformats.org/officeDocument/2006/relationships" id="270" r:id="Ra13314fcb3d948c0"/>
-    <p:sldId xmlns:r="http://schemas.openxmlformats.org/officeDocument/2006/relationships" id="271" r:id="Rdeafa39184b44817"/>
-    <p:sldId xmlns:r="http://schemas.openxmlformats.org/officeDocument/2006/relationships" id="272" r:id="Rc88c6170773b4445"/>
-    <p:sldId xmlns:r="http://schemas.openxmlformats.org/officeDocument/2006/relationships" id="273" r:id="R91c4e74996684001"/>
-    <p:sldId xmlns:r="http://schemas.openxmlformats.org/officeDocument/2006/relationships" id="274" r:id="Rba75cd7ca8d644bb"/>
-    <p:sldId xmlns:r="http://schemas.openxmlformats.org/officeDocument/2006/relationships" id="275" r:id="R822e02206aac4db0"/>
-    <p:sldId xmlns:r="http://schemas.openxmlformats.org/officeDocument/2006/relationships" id="276" r:id="R267b679d8f0d4a7e"/>
+    <p:sldId xmlns:r="http://schemas.openxmlformats.org/officeDocument/2006/relationships" id="256" r:id="Rf3c050d1ac2a454b"/>
+    <p:sldId xmlns:r="http://schemas.openxmlformats.org/officeDocument/2006/relationships" id="257" r:id="Rb51559de29564782"/>
+    <p:sldId xmlns:r="http://schemas.openxmlformats.org/officeDocument/2006/relationships" id="258" r:id="R90aaf76c3a5c4e1d"/>
+    <p:sldId xmlns:r="http://schemas.openxmlformats.org/officeDocument/2006/relationships" id="259" r:id="R40a41cf9c1244dc0"/>
+    <p:sldId xmlns:r="http://schemas.openxmlformats.org/officeDocument/2006/relationships" id="260" r:id="R7c7f2b3de6fe4c35"/>
+    <p:sldId xmlns:r="http://schemas.openxmlformats.org/officeDocument/2006/relationships" id="261" r:id="Re3645f0d14b349d5"/>
+    <p:sldId xmlns:r="http://schemas.openxmlformats.org/officeDocument/2006/relationships" id="262" r:id="R8b1fcb902ab44335"/>
+    <p:sldId xmlns:r="http://schemas.openxmlformats.org/officeDocument/2006/relationships" id="263" r:id="Rc7762e2e68514f6a"/>
+    <p:sldId xmlns:r="http://schemas.openxmlformats.org/officeDocument/2006/relationships" id="264" r:id="R591043ac794d4b0f"/>
+    <p:sldId xmlns:r="http://schemas.openxmlformats.org/officeDocument/2006/relationships" id="265" r:id="R331dacd6ec9148cb"/>
+    <p:sldId xmlns:r="http://schemas.openxmlformats.org/officeDocument/2006/relationships" id="266" r:id="R4bb86f7145df4ded"/>
+    <p:sldId xmlns:r="http://schemas.openxmlformats.org/officeDocument/2006/relationships" id="267" r:id="Rd7983dec5ff54417"/>
+    <p:sldId xmlns:r="http://schemas.openxmlformats.org/officeDocument/2006/relationships" id="268" r:id="R524c0f0d372047c9"/>
+    <p:sldId xmlns:r="http://schemas.openxmlformats.org/officeDocument/2006/relationships" id="269" r:id="R835796c7640e4f60"/>
+    <p:sldId xmlns:r="http://schemas.openxmlformats.org/officeDocument/2006/relationships" id="270" r:id="Rd030834ed2db497b"/>
+    <p:sldId xmlns:r="http://schemas.openxmlformats.org/officeDocument/2006/relationships" id="271" r:id="R2485e492acbd47fc"/>
+    <p:sldId xmlns:r="http://schemas.openxmlformats.org/officeDocument/2006/relationships" id="272" r:id="R0cb4185018ef40b6"/>
+    <p:sldId xmlns:r="http://schemas.openxmlformats.org/officeDocument/2006/relationships" id="273" r:id="R1edf11dda96c49be"/>
+    <p:sldId xmlns:r="http://schemas.openxmlformats.org/officeDocument/2006/relationships" id="274" r:id="R58338fb6f0664c10"/>
+    <p:sldId xmlns:r="http://schemas.openxmlformats.org/officeDocument/2006/relationships" id="275" r:id="Re6dc8a71c3a040d0"/>
+    <p:sldId xmlns:r="http://schemas.openxmlformats.org/officeDocument/2006/relationships" id="276" r:id="R15e14aa3cdc3489f"/>
   </p:sldIdLst>
   <p:sldSz cx="12192000" cy="6858000"/>
   <p:notesSz cx="6858000" cy="9144000"/>
@@ -3045,7 +3045,7 @@
   </p:cSld>
   <p:clrMap bg1="lt1" tx1="dk1" bg2="lt2" tx2="dk2" accent1="accent1" accent2="accent2" accent3="accent3" accent4="accent4" accent5="accent5" accent6="accent6" hlink="hlink" folHlink="folHlink"/>
   <p:sldLayoutIdLst>
-    <p:sldLayoutId xmlns:r="http://schemas.openxmlformats.org/officeDocument/2006/relationships" id="2147483649" r:id="R87e539e86b074209"/>
+    <p:sldLayoutId xmlns:r="http://schemas.openxmlformats.org/officeDocument/2006/relationships" id="2147483649" r:id="R5c95ba279c2448c9"/>
   </p:sldLayoutIdLst>
   <p:txStyles>
     <p:titleStyle>
@@ -3662,7 +3662,7 @@
           <p:nvPr/>
         </p:nvPicPr>
         <p:blipFill>
-          <a:blip xmlns:r="http://schemas.openxmlformats.org/officeDocument/2006/relationships" xmlns:a="http://schemas.openxmlformats.org/drawingml/2006/main" r:embed="Rbffc2ce2be9f4870"/>
+          <a:blip xmlns:r="http://schemas.openxmlformats.org/officeDocument/2006/relationships" xmlns:a="http://schemas.openxmlformats.org/drawingml/2006/main" r:embed="R5c6795e6cf2f4c25"/>
           <a:stretch xmlns:a="http://schemas.openxmlformats.org/drawingml/2006/main"/>
         </p:blipFill>
         <p:spPr>
@@ -4197,7 +4197,7 @@
           <p:nvPr/>
         </p:nvPicPr>
         <p:blipFill>
-          <a:blip xmlns:r="http://schemas.openxmlformats.org/officeDocument/2006/relationships" xmlns:a="http://schemas.openxmlformats.org/drawingml/2006/main" r:embed="Rb81092f53c32426d"/>
+          <a:blip xmlns:r="http://schemas.openxmlformats.org/officeDocument/2006/relationships" xmlns:a="http://schemas.openxmlformats.org/drawingml/2006/main" r:embed="R363263a8a7ad43a7"/>
           <a:stretch xmlns:a="http://schemas.openxmlformats.org/drawingml/2006/main"/>
         </p:blipFill>
         <p:spPr>
@@ -4333,7 +4333,7 @@
           <p:nvPr/>
         </p:nvPicPr>
         <p:blipFill>
-          <a:blip xmlns:r="http://schemas.openxmlformats.org/officeDocument/2006/relationships" xmlns:a="http://schemas.openxmlformats.org/drawingml/2006/main" r:embed="Rd0d0d26fbea74281"/>
+          <a:blip xmlns:r="http://schemas.openxmlformats.org/officeDocument/2006/relationships" xmlns:a="http://schemas.openxmlformats.org/drawingml/2006/main" r:embed="Rce79fbeaaef14429"/>
           <a:stretch xmlns:a="http://schemas.openxmlformats.org/drawingml/2006/main"/>
         </p:blipFill>
         <p:spPr>
@@ -4839,7 +4839,7 @@
                 <a:ea typeface="Calibri"/>
                 <a:cs typeface="Calibri"/>
               </a:rPr>
-              <a:t>Проверка аналитической формулой:</a:t>
+              <a:t>Аналитический контроль:</a:t>
             </a:r>
           </a:p>
           <a:p xmlns:a="http://schemas.openxmlformats.org/drawingml/2006/main">
@@ -4863,7 +4863,7 @@
                 <a:ea typeface="Calibri"/>
                 <a:cs typeface="Calibri"/>
               </a:rPr>
-              <a:t>расхождение менее 10⁻⁸.</a:t>
+              <a:t>ошибка &lt; 10⁻⁸.</a:t>
             </a:r>
           </a:p>
         </p:txBody>
@@ -5056,7 +5056,7 @@
           <p:nvPr/>
         </p:nvPicPr>
         <p:blipFill>
-          <a:blip xmlns:r="http://schemas.openxmlformats.org/officeDocument/2006/relationships" xmlns:a="http://schemas.openxmlformats.org/drawingml/2006/main" r:embed="R452349cdfe6c4d10"/>
+          <a:blip xmlns:r="http://schemas.openxmlformats.org/officeDocument/2006/relationships" xmlns:a="http://schemas.openxmlformats.org/drawingml/2006/main" r:embed="Rd1e5bddd0f0a48ee"/>
           <a:stretch xmlns:a="http://schemas.openxmlformats.org/drawingml/2006/main"/>
         </p:blipFill>
         <p:spPr>
@@ -5192,7 +5192,7 @@
           <p:nvPr/>
         </p:nvPicPr>
         <p:blipFill>
-          <a:blip xmlns:r="http://schemas.openxmlformats.org/officeDocument/2006/relationships" xmlns:a="http://schemas.openxmlformats.org/drawingml/2006/main" r:embed="Rd5444ac386fe43c1"/>
+          <a:blip xmlns:r="http://schemas.openxmlformats.org/officeDocument/2006/relationships" xmlns:a="http://schemas.openxmlformats.org/drawingml/2006/main" r:embed="R0f2edd62e4344e8f"/>
           <a:stretch xmlns:a="http://schemas.openxmlformats.org/drawingml/2006/main"/>
         </p:blipFill>
         <p:spPr>
@@ -5214,7 +5214,7 @@
           <p:nvPr/>
         </p:nvPicPr>
         <p:blipFill>
-          <a:blip xmlns:r="http://schemas.openxmlformats.org/officeDocument/2006/relationships" xmlns:a="http://schemas.openxmlformats.org/drawingml/2006/main" r:embed="R9e4a9dff9a334dcf"/>
+          <a:blip xmlns:r="http://schemas.openxmlformats.org/officeDocument/2006/relationships" xmlns:a="http://schemas.openxmlformats.org/drawingml/2006/main" r:embed="R35b530d6924c4300"/>
           <a:stretch xmlns:a="http://schemas.openxmlformats.org/drawingml/2006/main"/>
         </p:blipFill>
         <p:spPr>
@@ -5529,7 +5529,7 @@
           <p:nvPr/>
         </p:nvPicPr>
         <p:blipFill>
-          <a:blip xmlns:r="http://schemas.openxmlformats.org/officeDocument/2006/relationships" xmlns:a="http://schemas.openxmlformats.org/drawingml/2006/main" r:embed="Ra7a31429ef47400b"/>
+          <a:blip xmlns:r="http://schemas.openxmlformats.org/officeDocument/2006/relationships" xmlns:a="http://schemas.openxmlformats.org/drawingml/2006/main" r:embed="R3e072b44d2344668"/>
           <a:stretch xmlns:a="http://schemas.openxmlformats.org/drawingml/2006/main"/>
         </p:blipFill>
         <p:spPr>
@@ -5665,7 +5665,7 @@
           <p:nvPr/>
         </p:nvPicPr>
         <p:blipFill>
-          <a:blip xmlns:r="http://schemas.openxmlformats.org/officeDocument/2006/relationships" xmlns:a="http://schemas.openxmlformats.org/drawingml/2006/main" r:embed="R24eac0a69b6b4eb7"/>
+          <a:blip xmlns:r="http://schemas.openxmlformats.org/officeDocument/2006/relationships" xmlns:a="http://schemas.openxmlformats.org/drawingml/2006/main" r:embed="Rd1b8fb4f7d1d4621"/>
           <a:stretch xmlns:a="http://schemas.openxmlformats.org/drawingml/2006/main"/>
         </p:blipFill>
         <p:spPr>
@@ -6148,7 +6148,7 @@
           <p:nvPr/>
         </p:nvPicPr>
         <p:blipFill>
-          <a:blip xmlns:r="http://schemas.openxmlformats.org/officeDocument/2006/relationships" xmlns:a="http://schemas.openxmlformats.org/drawingml/2006/main" r:embed="Rdebaf8e7d56042e9"/>
+          <a:blip xmlns:r="http://schemas.openxmlformats.org/officeDocument/2006/relationships" xmlns:a="http://schemas.openxmlformats.org/drawingml/2006/main" r:embed="R9a3ccfc63eb64059"/>
           <a:stretch xmlns:a="http://schemas.openxmlformats.org/drawingml/2006/main"/>
         </p:blipFill>
         <p:spPr>
@@ -6284,7 +6284,7 @@
           <p:nvPr/>
         </p:nvPicPr>
         <p:blipFill>
-          <a:blip xmlns:r="http://schemas.openxmlformats.org/officeDocument/2006/relationships" xmlns:a="http://schemas.openxmlformats.org/drawingml/2006/main" r:embed="R5f37df514649453e"/>
+          <a:blip xmlns:r="http://schemas.openxmlformats.org/officeDocument/2006/relationships" xmlns:a="http://schemas.openxmlformats.org/drawingml/2006/main" r:embed="Reae17675eb3a4028"/>
           <a:stretch xmlns:a="http://schemas.openxmlformats.org/drawingml/2006/main"/>
         </p:blipFill>
         <p:spPr>
@@ -6306,7 +6306,7 @@
           <p:nvPr/>
         </p:nvPicPr>
         <p:blipFill>
-          <a:blip xmlns:r="http://schemas.openxmlformats.org/officeDocument/2006/relationships" xmlns:a="http://schemas.openxmlformats.org/drawingml/2006/main" r:embed="Re277463e30af48e8"/>
+          <a:blip xmlns:r="http://schemas.openxmlformats.org/officeDocument/2006/relationships" xmlns:a="http://schemas.openxmlformats.org/drawingml/2006/main" r:embed="R66f4d406841f46be"/>
           <a:stretch xmlns:a="http://schemas.openxmlformats.org/drawingml/2006/main"/>
         </p:blipFill>
         <p:spPr>
@@ -6502,7 +6502,7 @@
           <p:nvPr/>
         </p:nvPicPr>
         <p:blipFill>
-          <a:blip xmlns:r="http://schemas.openxmlformats.org/officeDocument/2006/relationships" xmlns:a="http://schemas.openxmlformats.org/drawingml/2006/main" r:embed="Rf887aa037ac24028"/>
+          <a:blip xmlns:r="http://schemas.openxmlformats.org/officeDocument/2006/relationships" xmlns:a="http://schemas.openxmlformats.org/drawingml/2006/main" r:embed="R9eb15e3f35184295"/>
           <a:stretch xmlns:a="http://schemas.openxmlformats.org/drawingml/2006/main"/>
         </p:blipFill>
         <p:spPr>
@@ -6963,7 +6963,7 @@
           <p:nvPr/>
         </p:nvPicPr>
         <p:blipFill>
-          <a:blip xmlns:r="http://schemas.openxmlformats.org/officeDocument/2006/relationships" xmlns:a="http://schemas.openxmlformats.org/drawingml/2006/main" r:embed="Rd9f487c661cd46bc"/>
+          <a:blip xmlns:r="http://schemas.openxmlformats.org/officeDocument/2006/relationships" xmlns:a="http://schemas.openxmlformats.org/drawingml/2006/main" r:embed="R3e5764c4df634db9"/>
           <a:stretch xmlns:a="http://schemas.openxmlformats.org/drawingml/2006/main"/>
         </p:blipFill>
         <p:spPr>
@@ -7099,7 +7099,7 @@
           <p:nvPr/>
         </p:nvPicPr>
         <p:blipFill>
-          <a:blip xmlns:r="http://schemas.openxmlformats.org/officeDocument/2006/relationships" xmlns:a="http://schemas.openxmlformats.org/drawingml/2006/main" r:embed="Re7a89f5246dc4146"/>
+          <a:blip xmlns:r="http://schemas.openxmlformats.org/officeDocument/2006/relationships" xmlns:a="http://schemas.openxmlformats.org/drawingml/2006/main" r:embed="Ra305c58af2124add"/>
           <a:stretch xmlns:a="http://schemas.openxmlformats.org/drawingml/2006/main"/>
         </p:blipFill>
         <p:spPr>
@@ -7605,7 +7605,7 @@
                 <a:ea typeface="Calibri"/>
                 <a:cs typeface="Calibri"/>
               </a:rPr>
-              <a:t>Отрезки — стандартные отклонения,</a:t>
+              <a:t>Отрезки: ±σ</a:t>
             </a:r>
           </a:p>
           <a:p xmlns:a="http://schemas.openxmlformats.org/drawingml/2006/main">
@@ -7629,7 +7629,7 @@
                 <a:ea typeface="Calibri"/>
                 <a:cs typeface="Calibri"/>
               </a:rPr>
-              <a:t>а не доверительные интервалы.</a:t>
+              <a:t>(стандартное отклонение)</a:t>
             </a:r>
           </a:p>
         </p:txBody>
@@ -7822,7 +7822,7 @@
           <p:nvPr/>
         </p:nvPicPr>
         <p:blipFill>
-          <a:blip xmlns:r="http://schemas.openxmlformats.org/officeDocument/2006/relationships" xmlns:a="http://schemas.openxmlformats.org/drawingml/2006/main" r:embed="Reecc31f539364eca"/>
+          <a:blip xmlns:r="http://schemas.openxmlformats.org/officeDocument/2006/relationships" xmlns:a="http://schemas.openxmlformats.org/drawingml/2006/main" r:embed="Ra5767e2e93d64bb3"/>
           <a:stretch xmlns:a="http://schemas.openxmlformats.org/drawingml/2006/main"/>
         </p:blipFill>
         <p:spPr>
@@ -7958,7 +7958,7 @@
           <p:nvPr/>
         </p:nvPicPr>
         <p:blipFill>
-          <a:blip xmlns:r="http://schemas.openxmlformats.org/officeDocument/2006/relationships" xmlns:a="http://schemas.openxmlformats.org/drawingml/2006/main" r:embed="Re8c9ba092e5e4a25"/>
+          <a:blip xmlns:r="http://schemas.openxmlformats.org/officeDocument/2006/relationships" xmlns:a="http://schemas.openxmlformats.org/drawingml/2006/main" r:embed="R2843e523b12c4c76"/>
           <a:stretch xmlns:a="http://schemas.openxmlformats.org/drawingml/2006/main"/>
         </p:blipFill>
         <p:spPr>
@@ -8417,7 +8417,7 @@
           <p:nvPr/>
         </p:nvPicPr>
         <p:blipFill>
-          <a:blip xmlns:r="http://schemas.openxmlformats.org/officeDocument/2006/relationships" xmlns:a="http://schemas.openxmlformats.org/drawingml/2006/main" r:embed="Rc235da63e1f34c7e"/>
+          <a:blip xmlns:r="http://schemas.openxmlformats.org/officeDocument/2006/relationships" xmlns:a="http://schemas.openxmlformats.org/drawingml/2006/main" r:embed="Rce1ddd6e26ad4246"/>
           <a:stretch xmlns:a="http://schemas.openxmlformats.org/drawingml/2006/main"/>
         </p:blipFill>
         <p:spPr>
@@ -8993,7 +8993,7 @@
           <p:nvPr/>
         </p:nvPicPr>
         <p:blipFill>
-          <a:blip xmlns:r="http://schemas.openxmlformats.org/officeDocument/2006/relationships" xmlns:a="http://schemas.openxmlformats.org/drawingml/2006/main" r:embed="R560e95f2e08f4971"/>
+          <a:blip xmlns:r="http://schemas.openxmlformats.org/officeDocument/2006/relationships" xmlns:a="http://schemas.openxmlformats.org/drawingml/2006/main" r:embed="R2d719e06051247a4"/>
           <a:stretch xmlns:a="http://schemas.openxmlformats.org/drawingml/2006/main"/>
         </p:blipFill>
         <p:spPr>
@@ -9129,7 +9129,7 @@
           <p:nvPr/>
         </p:nvPicPr>
         <p:blipFill>
-          <a:blip xmlns:r="http://schemas.openxmlformats.org/officeDocument/2006/relationships" xmlns:a="http://schemas.openxmlformats.org/drawingml/2006/main" r:embed="Rd08165804d03443b"/>
+          <a:blip xmlns:r="http://schemas.openxmlformats.org/officeDocument/2006/relationships" xmlns:a="http://schemas.openxmlformats.org/drawingml/2006/main" r:embed="R3eff107db9d548b9"/>
           <a:stretch xmlns:a="http://schemas.openxmlformats.org/drawingml/2006/main"/>
         </p:blipFill>
         <p:spPr>
@@ -9582,7 +9582,7 @@
           <p:nvPr/>
         </p:nvPicPr>
         <p:blipFill>
-          <a:blip xmlns:r="http://schemas.openxmlformats.org/officeDocument/2006/relationships" xmlns:a="http://schemas.openxmlformats.org/drawingml/2006/main" r:embed="R1c89cf64faa04674"/>
+          <a:blip xmlns:r="http://schemas.openxmlformats.org/officeDocument/2006/relationships" xmlns:a="http://schemas.openxmlformats.org/drawingml/2006/main" r:embed="R737b4f317a9e4ac2"/>
           <a:stretch xmlns:a="http://schemas.openxmlformats.org/drawingml/2006/main"/>
         </p:blipFill>
         <p:spPr>
@@ -9718,7 +9718,7 @@
           <p:nvPr/>
         </p:nvPicPr>
         <p:blipFill>
-          <a:blip xmlns:r="http://schemas.openxmlformats.org/officeDocument/2006/relationships" xmlns:a="http://schemas.openxmlformats.org/drawingml/2006/main" r:embed="R66a302b102fe4adc"/>
+          <a:blip xmlns:r="http://schemas.openxmlformats.org/officeDocument/2006/relationships" xmlns:a="http://schemas.openxmlformats.org/drawingml/2006/main" r:embed="R3f414217f7774ba1"/>
           <a:stretch xmlns:a="http://schemas.openxmlformats.org/drawingml/2006/main"/>
         </p:blipFill>
         <p:spPr>
@@ -10082,7 +10082,7 @@
           <p:nvPr/>
         </p:nvPicPr>
         <p:blipFill>
-          <a:blip xmlns:r="http://schemas.openxmlformats.org/officeDocument/2006/relationships" xmlns:a="http://schemas.openxmlformats.org/drawingml/2006/main" r:embed="R3fa5144979464514"/>
+          <a:blip xmlns:r="http://schemas.openxmlformats.org/officeDocument/2006/relationships" xmlns:a="http://schemas.openxmlformats.org/drawingml/2006/main" r:embed="Rc63e358b15594ac2"/>
           <a:stretch xmlns:a="http://schemas.openxmlformats.org/drawingml/2006/main"/>
         </p:blipFill>
         <p:spPr>
@@ -10543,7 +10543,7 @@
           <p:nvPr/>
         </p:nvPicPr>
         <p:blipFill>
-          <a:blip xmlns:r="http://schemas.openxmlformats.org/officeDocument/2006/relationships" xmlns:a="http://schemas.openxmlformats.org/drawingml/2006/main" r:embed="Rc3650bff5c9a429b"/>
+          <a:blip xmlns:r="http://schemas.openxmlformats.org/officeDocument/2006/relationships" xmlns:a="http://schemas.openxmlformats.org/drawingml/2006/main" r:embed="R4a01affe1804495c"/>
           <a:stretch xmlns:a="http://schemas.openxmlformats.org/drawingml/2006/main"/>
         </p:blipFill>
         <p:spPr>
@@ -11000,7 +11000,7 @@
           <p:nvPr/>
         </p:nvPicPr>
         <p:blipFill>
-          <a:blip xmlns:r="http://schemas.openxmlformats.org/officeDocument/2006/relationships" xmlns:a="http://schemas.openxmlformats.org/drawingml/2006/main" r:embed="R380b401a78904c0c"/>
+          <a:blip xmlns:r="http://schemas.openxmlformats.org/officeDocument/2006/relationships" xmlns:a="http://schemas.openxmlformats.org/drawingml/2006/main" r:embed="R9758b6d88ca64d06"/>
           <a:stretch xmlns:a="http://schemas.openxmlformats.org/drawingml/2006/main"/>
         </p:blipFill>
         <p:spPr>
@@ -11519,7 +11519,7 @@
           <p:nvPr/>
         </p:nvPicPr>
         <p:blipFill>
-          <a:blip xmlns:r="http://schemas.openxmlformats.org/officeDocument/2006/relationships" xmlns:a="http://schemas.openxmlformats.org/drawingml/2006/main" r:embed="R02a14726fc304937"/>
+          <a:blip xmlns:r="http://schemas.openxmlformats.org/officeDocument/2006/relationships" xmlns:a="http://schemas.openxmlformats.org/drawingml/2006/main" r:embed="Rbfa797247f634471"/>
           <a:stretch xmlns:a="http://schemas.openxmlformats.org/drawingml/2006/main"/>
         </p:blipFill>
         <p:spPr>
@@ -12095,7 +12095,7 @@
           <p:nvPr/>
         </p:nvPicPr>
         <p:blipFill>
-          <a:blip xmlns:r="http://schemas.openxmlformats.org/officeDocument/2006/relationships" xmlns:a="http://schemas.openxmlformats.org/drawingml/2006/main" r:embed="Rc6d797dff14b4925"/>
+          <a:blip xmlns:r="http://schemas.openxmlformats.org/officeDocument/2006/relationships" xmlns:a="http://schemas.openxmlformats.org/drawingml/2006/main" r:embed="Rcea4f1f8e9484861"/>
           <a:stretch xmlns:a="http://schemas.openxmlformats.org/drawingml/2006/main"/>
         </p:blipFill>
         <p:spPr>
@@ -12996,7 +12996,7 @@
           <p:nvPr/>
         </p:nvPicPr>
         <p:blipFill>
-          <a:blip xmlns:r="http://schemas.openxmlformats.org/officeDocument/2006/relationships" xmlns:a="http://schemas.openxmlformats.org/drawingml/2006/main" r:embed="R8cb84e8a3ef141e7"/>
+          <a:blip xmlns:r="http://schemas.openxmlformats.org/officeDocument/2006/relationships" xmlns:a="http://schemas.openxmlformats.org/drawingml/2006/main" r:embed="Rf862832915f34406"/>
           <a:stretch xmlns:a="http://schemas.openxmlformats.org/drawingml/2006/main"/>
         </p:blipFill>
         <p:spPr>
@@ -13132,7 +13132,7 @@
           <p:nvPr/>
         </p:nvPicPr>
         <p:blipFill>
-          <a:blip xmlns:r="http://schemas.openxmlformats.org/officeDocument/2006/relationships" xmlns:a="http://schemas.openxmlformats.org/drawingml/2006/main" r:embed="R08cb0faa292c433f"/>
+          <a:blip xmlns:r="http://schemas.openxmlformats.org/officeDocument/2006/relationships" xmlns:a="http://schemas.openxmlformats.org/drawingml/2006/main" r:embed="Rf82ce444f97f45c7"/>
           <a:stretch xmlns:a="http://schemas.openxmlformats.org/drawingml/2006/main"/>
         </p:blipFill>
         <p:spPr>
@@ -13638,7 +13638,7 @@
                 <a:ea typeface="Calibri"/>
                 <a:cs typeface="Calibri"/>
               </a:rPr>
-              <a:t>AlgebraicPetri → vectorfield</a:t>
+              <a:t>Сеть → ОДУ</a:t>
             </a:r>
           </a:p>
           <a:p xmlns:a="http://schemas.openxmlformats.org/drawingml/2006/main">
@@ -13662,7 +13662,7 @@
                 <a:ea typeface="Calibri"/>
                 <a:cs typeface="Calibri"/>
               </a:rPr>
-              <a:t>Дуги сети → изменения SSA</a:t>
+              <a:t>Дуги → SSA</a:t>
             </a:r>
           </a:p>
         </p:txBody>
@@ -13736,7 +13736,7 @@
           <p:nvPr/>
         </p:nvPicPr>
         <p:blipFill>
-          <a:blip xmlns:r="http://schemas.openxmlformats.org/officeDocument/2006/relationships" xmlns:a="http://schemas.openxmlformats.org/drawingml/2006/main" r:embed="R76209b852afe4d59"/>
+          <a:blip xmlns:r="http://schemas.openxmlformats.org/officeDocument/2006/relationships" xmlns:a="http://schemas.openxmlformats.org/drawingml/2006/main" r:embed="R671eac6db2ed467f"/>
           <a:stretch xmlns:a="http://schemas.openxmlformats.org/drawingml/2006/main"/>
         </p:blipFill>
         <p:spPr>
@@ -14197,7 +14197,7 @@
           <p:nvPr/>
         </p:nvPicPr>
         <p:blipFill>
-          <a:blip xmlns:r="http://schemas.openxmlformats.org/officeDocument/2006/relationships" xmlns:a="http://schemas.openxmlformats.org/drawingml/2006/main" r:embed="Re4f7ee9634544c3b"/>
+          <a:blip xmlns:r="http://schemas.openxmlformats.org/officeDocument/2006/relationships" xmlns:a="http://schemas.openxmlformats.org/drawingml/2006/main" r:embed="R9937f53f91a54d80"/>
           <a:stretch xmlns:a="http://schemas.openxmlformats.org/drawingml/2006/main"/>
         </p:blipFill>
         <p:spPr>
@@ -14773,7 +14773,7 @@
           <p:nvPr/>
         </p:nvPicPr>
         <p:blipFill>
-          <a:blip xmlns:r="http://schemas.openxmlformats.org/officeDocument/2006/relationships" xmlns:a="http://schemas.openxmlformats.org/drawingml/2006/main" r:embed="R583b4e3c54444c0d"/>
+          <a:blip xmlns:r="http://schemas.openxmlformats.org/officeDocument/2006/relationships" xmlns:a="http://schemas.openxmlformats.org/drawingml/2006/main" r:embed="R2da8c6e83c014905"/>
           <a:stretch xmlns:a="http://schemas.openxmlformats.org/drawingml/2006/main"/>
         </p:blipFill>
         <p:spPr>
@@ -15349,7 +15349,7 @@
           <p:nvPr/>
         </p:nvPicPr>
         <p:blipFill>
-          <a:blip xmlns:r="http://schemas.openxmlformats.org/officeDocument/2006/relationships" xmlns:a="http://schemas.openxmlformats.org/drawingml/2006/main" r:embed="Rddfa4c31f71a464d"/>
+          <a:blip xmlns:r="http://schemas.openxmlformats.org/officeDocument/2006/relationships" xmlns:a="http://schemas.openxmlformats.org/drawingml/2006/main" r:embed="R31fcd20729bf47e8"/>
           <a:stretch xmlns:a="http://schemas.openxmlformats.org/drawingml/2006/main"/>
         </p:blipFill>
         <p:spPr>
@@ -15485,7 +15485,7 @@
           <p:nvPr/>
         </p:nvPicPr>
         <p:blipFill>
-          <a:blip xmlns:r="http://schemas.openxmlformats.org/officeDocument/2006/relationships" xmlns:a="http://schemas.openxmlformats.org/drawingml/2006/main" r:embed="R0396f5d228a749a8"/>
+          <a:blip xmlns:r="http://schemas.openxmlformats.org/officeDocument/2006/relationships" xmlns:a="http://schemas.openxmlformats.org/drawingml/2006/main" r:embed="R3da26a4b00214b36"/>
           <a:stretch xmlns:a="http://schemas.openxmlformats.org/drawingml/2006/main"/>
         </p:blipFill>
         <p:spPr>
@@ -15507,7 +15507,7 @@
           <p:nvPr/>
         </p:nvPicPr>
         <p:blipFill>
-          <a:blip xmlns:r="http://schemas.openxmlformats.org/officeDocument/2006/relationships" xmlns:a="http://schemas.openxmlformats.org/drawingml/2006/main" r:embed="Rf6220c8d3a2a4bce"/>
+          <a:blip xmlns:r="http://schemas.openxmlformats.org/officeDocument/2006/relationships" xmlns:a="http://schemas.openxmlformats.org/drawingml/2006/main" r:embed="Ref0a9c96f5de4b2d"/>
           <a:stretch xmlns:a="http://schemas.openxmlformats.org/drawingml/2006/main"/>
         </p:blipFill>
         <p:spPr>

</xml_diff>